<commit_message>
Align presentation with assignment template and verify test dataset
</commit_message>
<xml_diff>
--- a/reports/MKB251-RazhnovAP_Итоговое_задание.pptx
+++ b/reports/MKB251-RazhnovAP_Итоговое_задание.pptx
@@ -2166,13 +2166,12 @@
               <a:buNone/>
             </a:pPr>
             <a:r>
-              <a:rPr lang="en-US" sz="1200">
-                <a:latin typeface="Proxima Nova"/>
-                <a:ea typeface="Proxima Nova"/>
-                <a:cs typeface="Proxima Nova"/>
-                <a:sym typeface="Proxima Nova"/>
+              <a:rPr lang="en-US">
+                <a:solidFill>
+                  <a:srgbClr val="0066FF"/>
+                </a:solidFill>
               </a:rPr>
-              <a:t>Результаты: artifacts/report.json, external_report.json, categories_report.json, data_report.json. Источники: https://spamassassin.apache.org/old/publiccorpus/ ; https://www2.aueb.gr/users/ion/data/enron-spam/ ; https://www2.aueb.gr/users/ion/data/lingspam_public.tar.gz ; https://huggingface.co/datasets/imnim/multiclass-email-classification . Корпус тем синтетический. Внешний teacher-test отсутствует по указанной ссылке.</a:t>
+              <a:t>Тестовый набор из задания: https://disk.yandex.ru/d/mJ_9zG3dX3eZgg . Файл test_task_emails.tar.xz, 1925712 байт; SHA256 14ccf52ab11673a85acab7c9793effa2c8db72c61838ba1b15356bd22d9576ee. Повторная проверка 20 октября 2026 года: 1600 исходных писем, 1545 после дедупликации; совпадает с ранее использованным тестом. Проверка сохранённой модели воспроизвела опубликованные метрики.</a:t>
             </a:r>
             <a:endParaRPr sz="1200">
               <a:solidFill>
@@ -2343,13 +2342,12 @@
               <a:buNone/>
             </a:pPr>
             <a:r>
-              <a:rPr lang="en-US" sz="1200">
-                <a:latin typeface="Proxima Nova"/>
-                <a:ea typeface="Proxima Nova"/>
-                <a:cs typeface="Proxima Nova"/>
-                <a:sym typeface="Proxima Nova"/>
+              <a:rPr lang="en-US">
+                <a:solidFill>
+                  <a:srgbClr val="0066FF"/>
+                </a:solidFill>
               </a:rPr>
-              <a:t>Результаты: artifacts/report.json, external_report.json, categories_report.json, data_report.json. Источники: https://spamassassin.apache.org/old/publiccorpus/ ; https://www2.aueb.gr/users/ion/data/enron-spam/ ; https://www2.aueb.gr/users/ion/data/lingspam_public.tar.gz ; https://huggingface.co/datasets/imnim/multiclass-email-classification . Корпус тем синтетический. Внешний teacher-test отсутствует по указанной ссылке.</a:t>
+              <a:t>Источник модуля URL-признаков: https://github.com/Andrey123654/Hakaton , src/features.py, commit afd2206d6d172b369b620d01ba10d6776219ad90. Происхождение и контрольная сумма: src/vendor/README.md.</a:t>
             </a:r>
             <a:endParaRPr sz="1200">
               <a:solidFill>
@@ -4447,7 +4445,7 @@
                 <a:cs typeface="Proxima Nova"/>
                 <a:sym typeface="Proxima Nova"/>
               </a:rPr>
-              <a:t>Результаты: artifacts/report.json, external_report.json, categories_report.json, data_report.json. Источники: https://spamassassin.apache.org/old/publiccorpus/ ; https://www2.aueb.gr/users/ion/data/enron-spam/ ; https://www2.aueb.gr/users/ion/data/lingspam_public.tar.gz ; https://huggingface.co/datasets/imnim/multiclass-email-classification . Корпус тем синтетический. Внешний teacher-test отсутствует по указанной ссылке.</a:t>
+              <a:t>Источники: https://spamassassin.apache.org/ ; https://scikit-learn.org/stable/auto_examples/text/plot_document_classification_20newsgroups.html . Сравнение F1: artifacts/hackathon_v2/metrics.json.</a:t>
             </a:r>
             <a:endParaRPr>
               <a:solidFill>
@@ -11664,7 +11662,7 @@
                 <a:cs typeface="Proxima Nova"/>
                 <a:sym typeface="Proxima Nova"/>
               </a:rPr>
-              <a:t>Антиспам на основе решения хакатона по фишингу</a:t>
+              <a:t>Антиспам-фильтр: NLP и категории писем</a:t>
             </a:r>
             <a:endParaRPr sz="1425">
               <a:solidFill>
@@ -11876,7 +11874,7 @@
             </a:pPr>
             <a:r>
               <a:rPr lang="en-US" sz="1800"/>
-              <a:t>Исходный пул: 9055 писем — SpamAssassin, Ling-Spam и 25 синтетических транзакционных примеров.</a:t>
+              <a:t>Источники: SpamAssassin, Ling-Spam и 25 синтетических транзакционных писем. Данные — тексты и метаданные писем.</a:t>
             </a:r>
             <a:endParaRPr sz="1800"/>
           </a:p>
@@ -11923,7 +11921,7 @@
             </a:pPr>
             <a:r>
               <a:rPr lang="en-US" sz="1800"/>
-              <a:t>1203 тестовых текста встречались в исходном пуле. После нормализации, дедупликации и полного удаления пересечений осталось 7848 писем.</a:t>
+              <a:t>Очистка MIME/HTML, нормализация, дедупликация и удаление 1203 совпадений с тестом. Подготовленный пул — 7848 писем.</a:t>
             </a:r>
             <a:endParaRPr sz="1800"/>
           </a:p>
@@ -11970,7 +11968,7 @@
             </a:pPr>
             <a:r>
               <a:rPr lang="en-US" sz="1800"/>
-              <a:t>Разбиение: 6278 development; 1570 validation; 1545 test. Все тестовые тексты исключены из первых двух частей.</a:t>
+              <a:t>development 6278: 4944 норма / 1334 спам.</a:t>
             </a:r>
             <a:endParaRPr sz="1800"/>
           </a:p>
@@ -11993,6 +11991,54 @@
               <a:buNone/>
             </a:pPr>
             <a:r>
+              <a:rPr lang="en-US" sz="1800"/>
+              <a:t>validation 1570: 1237 норма / 333 спам.</a:t>
+            </a:r>
+            <a:endParaRPr sz="1800"/>
+          </a:p>
+          <a:p>
+            <a:pPr indent="0" lvl="0" marL="0" marR="0" rtl="0" algn="l">
+              <a:lnSpc>
+                <a:spcPct val="100000"/>
+              </a:lnSpc>
+              <a:spcBef>
+                <a:spcPts val="0"/>
+              </a:spcBef>
+              <a:spcAft>
+                <a:spcPts val="0"/>
+              </a:spcAft>
+              <a:buClr>
+                <a:srgbClr val="000000"/>
+              </a:buClr>
+              <a:buSzPts val="1800"/>
+              <a:buFont typeface="Arial"/>
+              <a:buNone/>
+            </a:pPr>
+            <a:r>
+              <a:rPr lang="en-US" sz="1800"/>
+              <a:t>test 1545: 590 норма / 955 спам.</a:t>
+            </a:r>
+            <a:endParaRPr sz="1800"/>
+          </a:p>
+          <a:p>
+            <a:pPr indent="0" lvl="0" marL="0" marR="0" rtl="0" algn="l">
+              <a:lnSpc>
+                <a:spcPct val="100000"/>
+              </a:lnSpc>
+              <a:spcBef>
+                <a:spcPts val="0"/>
+              </a:spcBef>
+              <a:spcAft>
+                <a:spcPts val="0"/>
+              </a:spcAft>
+              <a:buClr>
+                <a:srgbClr val="000000"/>
+              </a:buClr>
+              <a:buSzPts val="1800"/>
+              <a:buFont typeface="Arial"/>
+              <a:buNone/>
+            </a:pPr>
+            <a:r>
               <a:t/>
             </a:r>
             <a:endParaRPr sz="1800"/>
@@ -12017,7 +12063,7 @@
             </a:pPr>
             <a:r>
               <a:rPr lang="en-US" sz="1800"/>
-              <a:t>SpamBase скачан, но его строки в обучении не используются. Основных текстовых корпусов два. Близкие дубликаты не группировались.</a:t>
+              <a:t>SpamBase — числовой набор; его строки в обучении не использованы. Текстовых корпусов два.</a:t>
             </a:r>
             <a:endParaRPr sz="1800"/>
           </a:p>
@@ -12228,7 +12274,7 @@
             </a:pPr>
             <a:r>
               <a:rPr lang="en-US" sz="1800"/>
-              <a:t>Из Hakaton перенесены 24 автономных признака URL. Для письма: максимум, среднее, число ссылок и усечение. Сетевых запросов по ссылкам нет.</a:t>
+              <a:t>5-fold CV на development. Мета-модель обучена на OOF-прогнозах; тест не участвует в выборе порога.</a:t>
             </a:r>
             <a:endParaRPr sz="1800"/>
           </a:p>
@@ -12275,7 +12321,7 @@
             </a:pPr>
             <a:r>
               <a:rPr lang="en-US" sz="1800"/>
-              <a:t>5-fold CV базовых моделей только на development. Финальная мета-модель обучается на OOF-прогнозах.</a:t>
+              <a:t>Validation: F1 = 0,98204; precision = 0,97910; recall = 0,98498; FP = 7/1237 (FPR = 0,57%).</a:t>
             </a:r>
             <a:endParaRPr sz="1800"/>
           </a:p>
@@ -12322,7 +12368,7 @@
             </a:pPr>
             <a:r>
               <a:rPr lang="en-US" sz="1800"/>
-              <a:t>Порог 0,710376 выбран на validation: максимум recall при FPR ≤ 1%. Тест не использовался для выбора порога.</a:t>
+              <a:t>Порог 0,710376 выбран по максимуму recall при FPR ≤ 1%. Разные представления дополняют друг друга; вклад отдельных групп ещё не измерен.</a:t>
             </a:r>
             <a:endParaRPr sz="1800"/>
           </a:p>
@@ -12486,7 +12532,7 @@
             </a:pPr>
             <a:r>
               <a:rPr lang="en-US" sz="1725"/>
-              <a:t>Весь локальный тест — 1545 писем:</a:t>
+              <a:t>Тест из задания: 1600 → 1545 писем после дедупликации:</a:t>
             </a:r>
             <a:endParaRPr sz="1725"/>
           </a:p>
@@ -12864,7 +12910,7 @@
             </a:pPr>
             <a:r>
               <a:rPr lang="en-US" sz="1725"/>
-              <a:t>Код антиспама: </a:t>
+              <a:t>Репозиторий проекта: </a:t>
             </a:r>
             <a:r>
               <a:rPr lang="en-US" sz="1725" u="sng">
@@ -12896,17 +12942,31 @@
               <a:buNone/>
             </a:pPr>
             <a:r>
+              <a:t/>
+            </a:r>
+            <a:endParaRPr sz="1725"/>
+          </a:p>
+          <a:p>
+            <a:pPr indent="0" lvl="0" marL="0" marR="0" rtl="0" algn="l">
+              <a:lnSpc>
+                <a:spcPct val="100000"/>
+              </a:lnSpc>
+              <a:spcBef>
+                <a:spcPts val="0"/>
+              </a:spcBef>
+              <a:spcAft>
+                <a:spcPts val="0"/>
+              </a:spcAft>
+              <a:buClr>
+                <a:srgbClr val="000000"/>
+              </a:buClr>
+              <a:buSzPts val="1725"/>
+              <a:buFont typeface="Arial"/>
+              <a:buNone/>
+            </a:pPr>
+            <a:r>
               <a:rPr lang="en-US" sz="1725"/>
-              <a:t>Основа хакатона: </a:t>
-            </a:r>
-            <a:r>
-              <a:rPr lang="en-US" sz="1725" u="sng">
-                <a:solidFill>
-                  <a:schemeClr val="hlink"/>
-                </a:solidFill>
-                <a:hlinkClick r:id="rId4"/>
-              </a:rPr>
-              <a:t>github.com/Andrey123654/Hakaton</a:t>
+              <a:t>Данные и признаки: src/load_data.py, src/features.py, src/hackathon_adapter.py.</a:t>
             </a:r>
             <a:endParaRPr sz="1725"/>
           </a:p>
@@ -12929,6 +12989,78 @@
               <a:buNone/>
             </a:pPr>
             <a:r>
+              <a:rPr lang="en-US" sz="1725"/>
+              <a:t>Обучение и оценка: src/adapt_hackathon.py.</a:t>
+            </a:r>
+            <a:endParaRPr sz="1725"/>
+          </a:p>
+          <a:p>
+            <a:pPr indent="0" lvl="0" marL="0" marR="0" rtl="0" algn="l">
+              <a:lnSpc>
+                <a:spcPct val="100000"/>
+              </a:lnSpc>
+              <a:spcBef>
+                <a:spcPts val="0"/>
+              </a:spcBef>
+              <a:spcAft>
+                <a:spcPts val="0"/>
+              </a:spcAft>
+              <a:buClr>
+                <a:srgbClr val="000000"/>
+              </a:buClr>
+              <a:buSzPts val="1725"/>
+              <a:buFont typeface="Arial"/>
+              <a:buNone/>
+            </a:pPr>
+            <a:r>
+              <a:rPr lang="en-US" sz="1725"/>
+              <a:t>Микросервис: service/app.py, Dockerfile.</a:t>
+            </a:r>
+            <a:endParaRPr sz="1725"/>
+          </a:p>
+          <a:p>
+            <a:pPr indent="0" lvl="0" marL="0" marR="0" rtl="0" algn="l">
+              <a:lnSpc>
+                <a:spcPct val="100000"/>
+              </a:lnSpc>
+              <a:spcBef>
+                <a:spcPts val="0"/>
+              </a:spcBef>
+              <a:spcAft>
+                <a:spcPts val="0"/>
+              </a:spcAft>
+              <a:buClr>
+                <a:srgbClr val="000000"/>
+              </a:buClr>
+              <a:buSzPts val="1725"/>
+              <a:buFont typeface="Arial"/>
+              <a:buNone/>
+            </a:pPr>
+            <a:r>
+              <a:rPr lang="en-US" sz="1725"/>
+              <a:t>Тетрадка: reports/Итоговое_задание.ipynb.</a:t>
+            </a:r>
+            <a:endParaRPr sz="1725"/>
+          </a:p>
+          <a:p>
+            <a:pPr indent="0" lvl="0" marL="0" marR="0" rtl="0" algn="l">
+              <a:lnSpc>
+                <a:spcPct val="100000"/>
+              </a:lnSpc>
+              <a:spcBef>
+                <a:spcPts val="0"/>
+              </a:spcBef>
+              <a:spcAft>
+                <a:spcPts val="0"/>
+              </a:spcAft>
+              <a:buClr>
+                <a:srgbClr val="000000"/>
+              </a:buClr>
+              <a:buSzPts val="1725"/>
+              <a:buFont typeface="Arial"/>
+              <a:buNone/>
+            </a:pPr>
+            <a:r>
               <a:t/>
             </a:r>
             <a:endParaRPr sz="1725"/>
@@ -12953,7 +13085,7 @@
             </a:pPr>
             <a:r>
               <a:rPr lang="en-US" sz="1725"/>
-              <a:t>src/vendor/hackathon_features.py — точная копия исходного модуля; commit и SHA256 записаны в отчёте.</a:t>
+              <a:t>Категории: реклама, работа, знакомства, финансы, доставка, безопасность и «прочее».</a:t>
             </a:r>
             <a:endParaRPr sz="1725"/>
           </a:p>
@@ -12977,102 +13109,7 @@
             </a:pPr>
             <a:r>
               <a:rPr lang="en-US" sz="1725"/>
-              <a:t>src/hackathon_adapter.py — перенос признаков на письма.</a:t>
-            </a:r>
-            <a:endParaRPr sz="1725"/>
-          </a:p>
-          <a:p>
-            <a:pPr indent="0" lvl="0" marL="0" marR="0" rtl="0" algn="l">
-              <a:lnSpc>
-                <a:spcPct val="100000"/>
-              </a:lnSpc>
-              <a:spcBef>
-                <a:spcPts val="0"/>
-              </a:spcBef>
-              <a:spcAft>
-                <a:spcPts val="0"/>
-              </a:spcAft>
-              <a:buClr>
-                <a:srgbClr val="000000"/>
-              </a:buClr>
-              <a:buSzPts val="1725"/>
-              <a:buFont typeface="Arial"/>
-              <a:buNone/>
-            </a:pPr>
-            <a:r>
-              <a:rPr lang="en-US" sz="1725"/>
-              <a:t>src/adapt_hackathon.py — обучение и единая оценка v2.</a:t>
-            </a:r>
-            <a:endParaRPr sz="1725"/>
-          </a:p>
-          <a:p>
-            <a:pPr indent="0" lvl="0" marL="0" marR="0" rtl="0" algn="l">
-              <a:lnSpc>
-                <a:spcPct val="100000"/>
-              </a:lnSpc>
-              <a:spcBef>
-                <a:spcPts val="0"/>
-              </a:spcBef>
-              <a:spcAft>
-                <a:spcPts val="0"/>
-              </a:spcAft>
-              <a:buClr>
-                <a:srgbClr val="000000"/>
-              </a:buClr>
-              <a:buSzPts val="1725"/>
-              <a:buFont typeface="Arial"/>
-              <a:buNone/>
-            </a:pPr>
-            <a:r>
-              <a:rPr lang="en-US" sz="1725"/>
-              <a:t>reports/Итоговое_задание.ipynb — выполненная тетрадка.</a:t>
-            </a:r>
-            <a:endParaRPr sz="1725"/>
-          </a:p>
-          <a:p>
-            <a:pPr indent="0" lvl="0" marL="0" marR="0" rtl="0" algn="l">
-              <a:lnSpc>
-                <a:spcPct val="100000"/>
-              </a:lnSpc>
-              <a:spcBef>
-                <a:spcPts val="0"/>
-              </a:spcBef>
-              <a:spcAft>
-                <a:spcPts val="0"/>
-              </a:spcAft>
-              <a:buClr>
-                <a:srgbClr val="000000"/>
-              </a:buClr>
-              <a:buSzPts val="1725"/>
-              <a:buFont typeface="Arial"/>
-              <a:buNone/>
-            </a:pPr>
-            <a:r>
-              <a:t/>
-            </a:r>
-            <a:endParaRPr sz="1725"/>
-          </a:p>
-          <a:p>
-            <a:pPr indent="0" lvl="0" marL="0" marR="0" rtl="0" algn="l">
-              <a:lnSpc>
-                <a:spcPct val="100000"/>
-              </a:lnSpc>
-              <a:spcBef>
-                <a:spcPts val="0"/>
-              </a:spcBef>
-              <a:spcAft>
-                <a:spcPts val="0"/>
-              </a:spcAft>
-              <a:buClr>
-                <a:srgbClr val="000000"/>
-              </a:buClr>
-              <a:buSzPts val="1725"/>
-              <a:buFont typeface="Arial"/>
-              <a:buNone/>
-            </a:pPr>
-            <a:r>
-              <a:rPr lang="en-US" sz="1725"/>
-              <a:t>Категории: 6 классов + «прочее»; macro-F1 = 0,72248. Слабая разметка правилами; отдельная унаследованная модель.</a:t>
+              <a:t>Macro-F1 = 0,72248; категории размечены правилами, не экспертами.</a:t>
             </a:r>
             <a:endParaRPr sz="1725"/>
           </a:p>
@@ -13673,7 +13710,7 @@
             </a:pPr>
             <a:r>
               <a:rPr lang="en-US" sz="1800"/>
-              <a:t>Итоговое задание развивает реальный код хакатона: признаки ссылок встроены в модель писем, OOF используется для обучения мета-модели.</a:t>
+              <a:t>Реализован цикл решения задачи: сбор и обработка данных, обучение, упаковка в Docker + FastAPI и публичная демонстрация.</a:t>
             </a:r>
             <a:endParaRPr sz="1800"/>
           </a:p>
@@ -13720,7 +13757,7 @@
             </a:pPr>
             <a:r>
               <a:rPr lang="en-US" sz="1800"/>
-              <a:t>F1 турнира 0,996062 относится к URL. F1 антиспама на полном тесте — 0,93878. Перенос метрик между задачами не допускается.</a:t>
+              <a:t>На полном локальном тесте: F1 = 0,93878; precision = 0,99184; recall = 0,89110. Дополнительно работает модель категорий письма.</a:t>
             </a:r>
             <a:endParaRPr sz="1800"/>
           </a:p>
@@ -13767,7 +13804,7 @@
             </a:pPr>
             <a:r>
               <a:rPr lang="en-US" sz="1800"/>
-              <a:t>FPR на тесте 1,19%, на сложном срезе — 7 из 24. Модель требует ручного контроля; преимущественно английские исторические корпуса ограничивают перенос.</a:t>
+              <a:t>FPR на тесте — 1,19%; на сложном срезе — 7 из 24. Автоматического удаления писем нет: решение требует ручного контроля.</a:t>
             </a:r>
             <a:endParaRPr sz="1800"/>
           </a:p>
@@ -13814,7 +13851,7 @@
             </a:pPr>
             <a:r>
               <a:rPr lang="en-US" sz="1800"/>
-              <a:t>Причинный прирост от URL-признаков пока не доказан отдельной абляцией.</a:t>
+              <a:t>Нужны свежий внешний тест, проверка по языкам и абляция групп признаков. Исторические английские корпуса ограничивают применение.</a:t>
             </a:r>
             <a:endParaRPr sz="1800"/>
           </a:p>
@@ -15622,7 +15659,7 @@
             </a:pPr>
             <a:r>
               <a:rPr lang="en-US" sz="1800"/>
-              <a:t>Цель: распознавать спам в письмах с приоритетом сохранения важной переписки.</a:t>
+              <a:t>Цель: реализовать полный цикл решения задачи машинного обучения — сбор и обработку данных, обучение, упаковку и публикацию модели.</a:t>
             </a:r>
             <a:endParaRPr sz="1800"/>
           </a:p>
@@ -15669,7 +15706,7 @@
             </a:pPr>
             <a:r>
               <a:rPr lang="en-US" sz="1800"/>
-              <a:t>Основа: авторская работа хакатона Hakaton — автономные признаки ссылок и OOF-стекинг.</a:t>
+              <a:t>Основное задание: разработать модель машинного обучения с использованием методов NLP, распознающую спам.</a:t>
             </a:r>
             <a:endParaRPr sz="1800"/>
           </a:p>
@@ -15716,7 +15753,7 @@
             </a:pPr>
             <a:r>
               <a:rPr lang="en-US" sz="1800"/>
-              <a:t>Результат: отдельно обученная модель писем, категории, FastAPI и Docker.</a:t>
+              <a:t>Дополнительное задание: определять категорию текста письма — реклама, предложение работы, знакомства и другие.</a:t>
             </a:r>
             <a:endParaRPr sz="1800"/>
           </a:p>
@@ -15763,7 +15800,7 @@
             </a:pPr>
             <a:r>
               <a:rPr lang="en-US" sz="1800"/>
-              <a:t>На локальном тесте: F1 = 0,93878; precision = 0,99184; FP = 7 из 590.</a:t>
+              <a:t>Результат проекта: антиспам-модель, классификатор категорий, микросервис Docker + FastAPI и публичное демо.</a:t>
             </a:r>
             <a:endParaRPr sz="1800"/>
           </a:p>
@@ -16365,7 +16402,7 @@
             <a:tbl>
               <a:tblPr>
                 <a:noFill/>
-                <a:tableStyleId>{BBAA868F-7CFB-42DF-91E8-6444F7D2DF13}</a:tableStyleId>
+                <a:tableStyleId>{1166CBF2-9642-4AC4-8CFD-A4399D60F063}</a:tableStyleId>
               </a:tblPr>
               <a:tblGrid>
                 <a:gridCol w="3744125"/>
@@ -16618,8 +16655,8 @@
                         <a:buNone/>
                       </a:pPr>
                       <a:r>
-                        <a:rPr lang="en-US" sz="1425" u="none" cap="none" strike="noStrike"/>
-                        <a:t>Внешний тест и анализ ошибок</a:t>
+                        <a:rPr lang="en-US" sz="1425"/>
+                        <a:t>Тестирование и анализ ошибок</a:t>
                       </a:r>
                       <a:endParaRPr sz="1400" u="none" cap="none" strike="noStrike"/>
                     </a:p>
@@ -16888,7 +16925,7 @@
             </a:pPr>
             <a:r>
               <a:rPr lang="en-US" sz="1800"/>
-              <a:t>1. Зафиксировать исходный код решения хакатона и переносимые признаки.</a:t>
+              <a:t>0. Анализ существующих подходов и постановка задачи.</a:t>
             </a:r>
             <a:endParaRPr sz="1800"/>
           </a:p>
@@ -16912,7 +16949,7 @@
             </a:pPr>
             <a:r>
               <a:rPr lang="en-US" sz="1800"/>
-              <a:t>2. Подготовить SpamAssassin и Ling-Spam, удалить пересечения с тестом.</a:t>
+              <a:t>1. Сбор и обработка данных из нескольких корпусов.</a:t>
             </a:r>
             <a:endParaRPr sz="1800"/>
           </a:p>
@@ -16936,7 +16973,7 @@
             </a:pPr>
             <a:r>
               <a:rPr lang="en-US" sz="1800"/>
-              <a:t>3. Обучить четыре базовые модели; получить OOF для мета-модели.</a:t>
+              <a:t>2. Обучение, кросс-валидация, F1 / precision / recall; приоритет — низкий FPR.</a:t>
             </a:r>
             <a:endParaRPr sz="1800"/>
           </a:p>
@@ -16960,7 +16997,7 @@
             </a:pPr>
             <a:r>
               <a:rPr lang="en-US" sz="1800"/>
-              <a:t>4. Выбрать порог на validation при FPR ≤ 1%.</a:t>
+              <a:t>3. Упаковка модели в Docker + FastAPI.</a:t>
             </a:r>
             <a:endParaRPr sz="1800"/>
           </a:p>
@@ -16984,7 +17021,7 @@
             </a:pPr>
             <a:r>
               <a:rPr lang="en-US" sz="1800"/>
-              <a:t>5. Проверить одну модель на всём тесте и исторически новом срезе.</a:t>
+              <a:t>4. Публикация модели и демонстрационного интерфейса.</a:t>
             </a:r>
             <a:endParaRPr sz="1800"/>
           </a:p>
@@ -17008,7 +17045,7 @@
             </a:pPr>
             <a:r>
               <a:rPr lang="en-US" sz="1800"/>
-              <a:t>6. Упаковать FastAPI + Docker, опубликовать и подготовить защиту.</a:t>
+              <a:t>5–6. Презентация по шаблону, проверка доступа и передача ссылки в LMS.</a:t>
             </a:r>
             <a:endParaRPr sz="1800"/>
           </a:p>
@@ -17903,7 +17940,7 @@
             </a:pPr>
             <a:r>
               <a:rPr lang="en-US" sz="1800"/>
-              <a:t>Бизнес-задача: уменьшить ручную проверку нежелательной почты, сохранив важные письма.</a:t>
+              <a:t>Бизнес-задача: распознавать нежелательную почту, сохраняя важные письма.</a:t>
             </a:r>
             <a:endParaRPr sz="1800"/>
           </a:p>
@@ -17950,7 +17987,7 @@
             </a:pPr>
             <a:r>
               <a:rPr lang="en-US" sz="1800"/>
-              <a:t>ML-задача: spam / ham по теме, тексту и структуре ссылок в письме.</a:t>
+              <a:t>ML-задача: бинарная классификация spam / ham методами NLP.</a:t>
             </a:r>
             <a:endParaRPr sz="1800"/>
           </a:p>
@@ -17997,7 +18034,7 @@
             </a:pPr>
             <a:r>
               <a:rPr lang="en-US" sz="1800"/>
-              <a:t>Работа хакатона распознавала фишинговые URL. Здесь перенесён её модуль признаков; метки и веса модели обучены на письмах.</a:t>
+              <a:t>Вход: тема, текст и отправитель. Выход: вероятность спама, решение и категория письма.</a:t>
             </a:r>
             <a:endParaRPr sz="1800"/>
           </a:p>
@@ -18044,7 +18081,7 @@
             </a:pPr>
             <a:r>
               <a:rPr lang="en-US" sz="1800"/>
-              <a:t>Вход: subject, text, sender. Выход: spam score, решение, порог, категория и признаки ссылок.</a:t>
+              <a:t>Приоритет — низкий FPR; precision, recall и F1 показывают баланс ошибок.</a:t>
             </a:r>
             <a:endParaRPr sz="1800"/>
           </a:p>
@@ -18091,7 +18128,7 @@
             </a:pPr>
             <a:r>
               <a:rPr lang="en-US" sz="1800"/>
-              <a:t>Автоматического удаления писем нет.</a:t>
+              <a:t>Требование: интерактивный ответ за несколько секунд. Холодный старт хостинга учитывается отдельно.</a:t>
             </a:r>
             <a:endParaRPr sz="1800"/>
           </a:p>
@@ -18255,7 +18292,7 @@
             </a:pPr>
             <a:r>
               <a:rPr lang="en-US" sz="1800"/>
-              <a:t>Правила: объяснимы, но требуют ручного сопровождения и плохо покрывают новые формулировки.</a:t>
+              <a:t>Apache SpamAssassin объединяет эвристические и статистические проверки заголовков и текста письма, включая байесовскую фильтрацию.</a:t>
             </a:r>
             <a:endParaRPr sz="1800"/>
           </a:p>
@@ -18302,7 +18339,7 @@
             </a:pPr>
             <a:r>
               <a:rPr lang="en-US" sz="1800"/>
-              <a:t>TF-IDF + LR / SVM / ComplementNB: базовые модели для разреженного текста; HistGB использует числовые признаки и SVD.</a:t>
+              <a:t>TF-IDF + LR / SVM / ComplementNB — базовые подходы к классификации разреженного текста. Бустинг использует числовые признаки и SVD.</a:t>
             </a:r>
             <a:endParaRPr sz="1800"/>
           </a:p>
@@ -18349,7 +18386,7 @@
             </a:pPr>
             <a:r>
               <a:rPr lang="en-US" sz="1800"/>
-              <a:t>Основа Hakaton: структура URL, бренды, тайпсквоттинг и объединение разных представлений через OOF.</a:t>
+              <a:t>На нашей validation: F1 текстовой LR = 0,98068; стекинга = 0,98204.</a:t>
             </a:r>
             <a:endParaRPr sz="1800"/>
           </a:p>
@@ -18396,7 +18433,7 @@
             </a:pPr>
             <a:r>
               <a:rPr lang="en-US" sz="1800"/>
-              <a:t>На validation: F1 текстовой LR = 0,98068; стекинга = 0,98204. Изолированный вклад URL-признаков ещё не измерен.</a:t>
+              <a:t>Выбран стекинг разных представлений письма. Отдельный вклад групп признаков ещё требует абляции.</a:t>
             </a:r>
             <a:endParaRPr sz="1800"/>
           </a:p>

</xml_diff>